<commit_message>
Training 0-2 for the 0.9.0 Present screen: the wall, Idle, builds, Focus
The decks, services, outlines, cheat sheet and videos no longer teach the
order/live/next layout or the Logo screen.

- "The Present screen" deck: the wall, red LIVE, gold NEXT and the strip
  on top; Show, Idle and Blank; Focus in the trainer's notes.
- "Blank, Logo, Clear" becomes "Blank, Idle, Clear" (t1-blank-idle-clear),
  with a new Idle scene.
- "Going live" gains the builds panel and Focus scenes; callouts point at
  the LIVE and NEXT cards and the strip.
- Notes now sit beside the item on air, not in a Notes pane.
- Cheat sheet: Idle replaces Logo; Focus (F, Esc); LIVE and NEXT cards.
- Capture mock: Next plays build steps, deck slides are pictures drawn at
  their step, and the idle preview is a small logo. New shots focus.png
  and idle.png; every training shot retaken.
- Narration re-synthesised with the same Chirp 3 HD voice (Algenib).

Co-Authored-By: Claude Opus 5.5 <noreply@anthropic.com>
</commit_message>
<xml_diff>
--- a/training/decks/t0-plan-and-present.pptx
+++ b/training/decks/t0-plan-and-present.pptx
@@ -676,12 +676,17 @@
           <a:lstStyle/>
           <a:p>
             <a:r>
-              <a:t>Trainer: Present is the operator's screen. One service is open at a time.</a:t>
-            </a:r>
-          </a:p>
-          <a:p>
-            <a:r>
-              <a:t>The big picture with the red frame is what the room sees. Everything else is only for you.</a:t>
+              <a:t>Trainer: Present is the operator's screen. One service is open at a time, and every slide</a:t>
+            </a:r>
+          </a:p>
+          <a:p>
+            <a:r>
+              <a:t>of it is laid out as cards. The card marked LIVE, in red, is what the room sees, and so is the</a:t>
+            </a:r>
+          </a:p>
+          <a:p>
+            <a:r>
+              <a:t>small picture at the top left. Everything else is only for you.</a:t>
             </a:r>
           </a:p>
           <a:p>

</xml_diff>

<commit_message>
Training: say what it is, not 'a training'; Training Session N; Present said pri-ZENT
- No countable 'training': 'training service', 'this short video'.
- Rename Training 0/1/2 to Training Session 0/1/2 in services, decks, sheet, outlines, narration, docs, tests.
- video/core/pronunciations.json: shared IPA map passed to every narration; Present is prɪˈzɛnt.
- Narration, screenshots, decks, sheet and videos regenerated.

Co-Authored-By: Claude Opus 5.5 <noreply@anthropic.com>
</commit_message>
<xml_diff>
--- a/training/decks/t0-plan-and-present.pptx
+++ b/training/decks/t0-plan-and-present.pptx
@@ -691,7 +691,7 @@
           </a:p>
           <a:p>
             <a:r>
-              <a:t>This training is itself a service, open in Present right now.</a:t>
+              <a:t>This training service is open in Present right now, and it works like any other service.</a:t>
             </a:r>
           </a:p>
         </p:txBody>
@@ -3899,7 +3899,7 @@
                 </a:solidFill>
                 <a:latin typeface="Noto Sans"/>
               </a:rPr>
-              <a:t>Training 0</a:t>
+              <a:t>Training Session 0</a:t>
             </a:r>
           </a:p>
         </p:txBody>

</xml_diff>